<commit_message>
dbms theory add unit 4-5 pdf
</commit_message>
<xml_diff>
--- a/Sem-1/RDBMS Theory/Unit-4/Unit-4.pptx
+++ b/Sem-1/RDBMS Theory/Unit-4/Unit-4.pptx
@@ -257,7 +257,7 @@
           <a:p>
             <a:fld id="{4A2E5D5B-4CE0-4E6F-84BE-A53E645E58F0}" type="datetimeFigureOut">
               <a:rPr lang="en-IN" smtClean="0"/>
-              <a:t>13-12-2025</a:t>
+              <a:t>17-12-2025</a:t>
             </a:fld>
             <a:endParaRPr lang="en-IN" dirty="0"/>
           </a:p>
@@ -1271,7 +1271,7 @@
             <a:fld id="{B61BEF0D-F0BB-DE4B-95CE-6DB70DBA9567}" type="datetimeFigureOut">
               <a:rPr lang="en-US" dirty="0"/>
               <a:pPr/>
-              <a:t>12/13/2025</a:t>
+              <a:t>12/17/2025</a:t>
             </a:fld>
             <a:endParaRPr lang="en-US" dirty="0"/>
           </a:p>
@@ -1519,7 +1519,7 @@
             <a:fld id="{B61BEF0D-F0BB-DE4B-95CE-6DB70DBA9567}" type="datetimeFigureOut">
               <a:rPr lang="en-US" dirty="0"/>
               <a:pPr/>
-              <a:t>12/13/2025</a:t>
+              <a:t>12/17/2025</a:t>
             </a:fld>
             <a:endParaRPr lang="en-US" dirty="0"/>
           </a:p>
@@ -1830,7 +1830,7 @@
             <a:fld id="{B61BEF0D-F0BB-DE4B-95CE-6DB70DBA9567}" type="datetimeFigureOut">
               <a:rPr lang="en-US" dirty="0"/>
               <a:pPr/>
-              <a:t>12/13/2025</a:t>
+              <a:t>12/17/2025</a:t>
             </a:fld>
             <a:endParaRPr lang="en-US" dirty="0"/>
           </a:p>
@@ -2160,7 +2160,7 @@
             <a:fld id="{B61BEF0D-F0BB-DE4B-95CE-6DB70DBA9567}" type="datetimeFigureOut">
               <a:rPr lang="en-US" dirty="0"/>
               <a:pPr/>
-              <a:t>12/13/2025</a:t>
+              <a:t>12/17/2025</a:t>
             </a:fld>
             <a:endParaRPr lang="en-US" dirty="0"/>
           </a:p>
@@ -2471,7 +2471,7 @@
             <a:fld id="{B61BEF0D-F0BB-DE4B-95CE-6DB70DBA9567}" type="datetimeFigureOut">
               <a:rPr lang="en-US" dirty="0"/>
               <a:pPr/>
-              <a:t>12/13/2025</a:t>
+              <a:t>12/17/2025</a:t>
             </a:fld>
             <a:endParaRPr lang="en-US" dirty="0"/>
           </a:p>
@@ -2861,7 +2861,7 @@
             <a:fld id="{B61BEF0D-F0BB-DE4B-95CE-6DB70DBA9567}" type="datetimeFigureOut">
               <a:rPr lang="en-US" dirty="0"/>
               <a:pPr/>
-              <a:t>12/13/2025</a:t>
+              <a:t>12/17/2025</a:t>
             </a:fld>
             <a:endParaRPr lang="en-US" dirty="0"/>
           </a:p>
@@ -3027,7 +3027,7 @@
           <a:p>
             <a:fld id="{55C6B4A9-1611-4792-9094-5F34BCA07E0B}" type="datetimeFigureOut">
               <a:rPr lang="en-US" dirty="0"/>
-              <a:t>12/13/2025</a:t>
+              <a:t>12/17/2025</a:t>
             </a:fld>
             <a:endParaRPr lang="en-US" dirty="0"/>
           </a:p>
@@ -3203,7 +3203,7 @@
             <a:fld id="{B61BEF0D-F0BB-DE4B-95CE-6DB70DBA9567}" type="datetimeFigureOut">
               <a:rPr lang="en-US" dirty="0"/>
               <a:pPr/>
-              <a:t>12/13/2025</a:t>
+              <a:t>12/17/2025</a:t>
             </a:fld>
             <a:endParaRPr lang="en-US" dirty="0"/>
           </a:p>
@@ -3369,7 +3369,7 @@
           <a:p>
             <a:fld id="{42A54C80-263E-416B-A8E0-580EDEADCBDC}" type="datetimeFigureOut">
               <a:rPr lang="en-US" dirty="0"/>
-              <a:t>12/13/2025</a:t>
+              <a:t>12/17/2025</a:t>
             </a:fld>
             <a:endParaRPr lang="en-US" dirty="0"/>
           </a:p>
@@ -3612,7 +3612,7 @@
             <a:fld id="{B61BEF0D-F0BB-DE4B-95CE-6DB70DBA9567}" type="datetimeFigureOut">
               <a:rPr lang="en-US" dirty="0"/>
               <a:pPr/>
-              <a:t>12/13/2025</a:t>
+              <a:t>12/17/2025</a:t>
             </a:fld>
             <a:endParaRPr lang="en-US" dirty="0"/>
           </a:p>
@@ -3840,7 +3840,7 @@
           <a:p>
             <a:fld id="{42A54C80-263E-416B-A8E0-580EDEADCBDC}" type="datetimeFigureOut">
               <a:rPr lang="en-US" dirty="0"/>
-              <a:t>12/13/2025</a:t>
+              <a:t>12/17/2025</a:t>
             </a:fld>
             <a:endParaRPr lang="en-US" dirty="0"/>
           </a:p>
@@ -4210,7 +4210,7 @@
             <a:fld id="{B61BEF0D-F0BB-DE4B-95CE-6DB70DBA9567}" type="datetimeFigureOut">
               <a:rPr lang="en-US" dirty="0"/>
               <a:pPr/>
-              <a:t>12/13/2025</a:t>
+              <a:t>12/17/2025</a:t>
             </a:fld>
             <a:endParaRPr lang="en-US" dirty="0"/>
           </a:p>
@@ -4330,7 +4330,7 @@
             <a:fld id="{B61BEF0D-F0BB-DE4B-95CE-6DB70DBA9567}" type="datetimeFigureOut">
               <a:rPr lang="en-US" dirty="0"/>
               <a:pPr/>
-              <a:t>12/13/2025</a:t>
+              <a:t>12/17/2025</a:t>
             </a:fld>
             <a:endParaRPr lang="en-US" dirty="0"/>
           </a:p>
@@ -4422,7 +4422,7 @@
             <a:fld id="{B61BEF0D-F0BB-DE4B-95CE-6DB70DBA9567}" type="datetimeFigureOut">
               <a:rPr lang="en-US" dirty="0"/>
               <a:pPr/>
-              <a:t>12/13/2025</a:t>
+              <a:t>12/17/2025</a:t>
             </a:fld>
             <a:endParaRPr lang="en-US" dirty="0"/>
           </a:p>
@@ -4673,7 +4673,7 @@
           <a:p>
             <a:fld id="{42A54C80-263E-416B-A8E0-580EDEADCBDC}" type="datetimeFigureOut">
               <a:rPr lang="en-US" dirty="0"/>
-              <a:t>12/13/2025</a:t>
+              <a:t>12/17/2025</a:t>
             </a:fld>
             <a:endParaRPr lang="en-US" dirty="0"/>
           </a:p>
@@ -4974,7 +4974,7 @@
             <a:fld id="{B61BEF0D-F0BB-DE4B-95CE-6DB70DBA9567}" type="datetimeFigureOut">
               <a:rPr lang="en-US" dirty="0"/>
               <a:pPr/>
-              <a:t>12/13/2025</a:t>
+              <a:t>12/17/2025</a:t>
             </a:fld>
             <a:endParaRPr lang="en-US" dirty="0"/>
           </a:p>
@@ -5672,7 +5672,7 @@
             <a:fld id="{B61BEF0D-F0BB-DE4B-95CE-6DB70DBA9567}" type="datetimeFigureOut">
               <a:rPr lang="en-US" dirty="0"/>
               <a:pPr/>
-              <a:t>12/13/2025</a:t>
+              <a:t>12/17/2025</a:t>
             </a:fld>
             <a:endParaRPr lang="en-US" dirty="0"/>
           </a:p>
@@ -6692,7 +6692,7 @@
           <a:p>
             <a:r>
               <a:rPr lang="en-US" sz="1200" i="1" dirty="0"/>
-              <a:t>09/11/2025</a:t>
+              <a:t>12/12/2025</a:t>
             </a:r>
             <a:endParaRPr lang="en-IN" sz="1200" i="1" dirty="0"/>
           </a:p>

</xml_diff>